<commit_message>
Improve presentation PPTX demos and speaker notes
</commit_message>
<xml_diff>
--- a/presentation/slides.pptx
+++ b/presentation/slides.pptx
@@ -516,7 +516,8 @@
           <a:p>
             <a:r>
               <a:rPr lang="en-US" dirty="0"/>
-              <a:t/>
+              <a:t>Hi everyone. · I'm June Gu, and today I'm presenting `llm-smart-router` — a multi-model AI agent orchestrator I built this semester for 06-642.
+---</a:t>
             </a:r>
             <a:endParaRPr lang="en-US" dirty="0"/>
           </a:p>
@@ -604,7 +605,9 @@
           <a:p>
             <a:r>
               <a:rPr lang="en-US" dirty="0"/>
-              <a:t/>
+              <a:t>On the evidence side: the project has one hundred sixty-seven automated tests across fourteen test files. · That includes the full routing logic, team orchestration, CLI hybrid mode, session persistence, and provider fallback chains. · I also added dedicated tests this semester for the CLI hybrid branch specifically — verifying that when CLI mode is on, no API tokens are consumed.
+GitHub Actions runs the full test suite on Node twenty and twenty-two on every push. · Both matrix legs are green at the current commit.
+---</a:t>
             </a:r>
             <a:endParaRPr lang="en-US" dirty="0"/>
           </a:p>
@@ -692,7 +695,10 @@
           <a:p>
             <a:r>
               <a:rPr lang="en-US" dirty="0"/>
-              <a:t/>
+              <a:t>Let me put this in context of the semester. · Project 1 was `plateprep` — a narrow Python CLI for one lab task. No external APIs. · Claude Code was mostly a scaffolding tool there.
+Project 2 was the first version of this tool — TypeScript CLI, smart routing, team mode, one hundred fifty-four tests. · I started using Claude Code more as a design partner.
+For the final project, I added GitHub Actions CI, the `--use-cli` zero-cost hybrid, the Next.js web UI with Supabase auth on Vercel, and a Karpathy-style project wiki for persistent context across sessions. · Each step was the same tool, but a deeper understanding of what "polished" actually means.
+---</a:t>
             </a:r>
             <a:endParaRPr lang="en-US" dirty="0"/>
           </a:p>
@@ -780,7 +786,11 @@
           <a:p>
             <a:r>
               <a:rPr lang="en-US" dirty="0"/>
-              <a:t/>
+              <a:t>Here's what I learned about working with AI coding agents over the semester.
+At the beginning, my mental model was: AI writes a draft, I fix it. · By Project 2, I shifted to specifying failure cases *before* implementation, not after — because fixing a broken timeout handler after it's in three places is much harder than saying upfront "this must fail with a clear message after one hundred twenty seconds."
+For the final project, I started using plan mode before any significant change, and built a wiki system so each new session started with full project context rather than from scratch.
+But the meta-moment — · I used Claude Code to build a tool that runs Claude, Gemini, and Codex as parallel subprocesses. · The orchestrator was built by an agent. · The agents it orchestrates include the agent that built it.
+---</a:t>
             </a:r>
             <a:endParaRPr lang="en-US" dirty="0"/>
           </a:p>
@@ -868,7 +878,8 @@
           <a:p>
             <a:r>
               <a:rPr lang="en-US" dirty="0"/>
-              <a:t/>
+              <a:t>To be honest about the limitations: · provider setup still requires manually configuring API keys — a guided `smart-router auth` wizard would lower that barrier significantly. · The router handles clear-cut task types well but struggles with mixed prompts, like something that's both a math derivation and a code implementation. · The cross-model verification pipeline I describe in the README — Claude authors, Gemini verifies, Codex challenges — isn't yet implemented as a preset. · And the web UI, while functional, still requires a GitHub login which limits who can try it independently.
+---</a:t>
             </a:r>
             <a:endParaRPr lang="en-US" dirty="0"/>
           </a:p>
@@ -956,7 +967,8 @@
           <a:p>
             <a:r>
               <a:rPr lang="en-US" dirty="0"/>
-              <a:t/>
+              <a:t>That's `llm-smart-router`. · Route your work to the best model, run parallel agent teams, and pay zero with your existing subscriptions. · The repo is public at the address on screen.
+---</a:t>
             </a:r>
             <a:endParaRPr lang="en-US" dirty="0"/>
           </a:p>
@@ -1044,7 +1056,7 @@
           <a:p>
             <a:r>
               <a:rPr lang="en-US" dirty="0"/>
-              <a:t/>
+              <a:t>I'll now open it up for questions.</a:t>
             </a:r>
             <a:endParaRPr lang="en-US" dirty="0"/>
           </a:p>
@@ -1132,7 +1144,9 @@
           <a:p>
             <a:r>
               <a:rPr lang="en-US" dirty="0"/>
-              <a:t/>
+              <a:t>Let me start with the problem. · When you're building with AI today, you have access to a lot of different models — Claude, Gemini, GPT, DeepSeek. · And they're genuinely different. · Claude Sonnet is the benchmark leader for code generation. · Gemini 2.5 Pro has a one-million-token context window, which is essential for long documents. · DeepSeek R1 can do mathematical reasoning at fifty-four times cheaper than Claude for comparable accuracy. · And DeepSeek V3 costs less than three cents per million tokens for general tasks.
+The problem is that most developers either default to one expensive premium model for everything — which is wasteful — or they manually switch between providers, which is friction. · Neither is good. · **Switching manually is friction. Choosing wrong is waste.**
+---</a:t>
             </a:r>
             <a:endParaRPr lang="en-US" dirty="0"/>
           </a:p>
@@ -1220,7 +1234,12 @@
           <a:p>
             <a:r>
               <a:rPr lang="en-US" dirty="0"/>
-              <a:t/>
+              <a:t>So here's the solution in three commands.
+First: you just type your prompt. · The tool automatically classifies the task and routes it to the best available model. · "Implement a binary search tree in Python" goes straight to Claude Sonnet.
+Second: for larger tasks, you can run a multi-model team. · `--preset code-review` spins up a SecurityReviewer, a QualityReviewer, and a DocReviewer in parallel — they all look at your code change independently, and a leader model synthesizes their findings.
+Third — and this is the headline feature — · `--use-cli` runs the whole team at zero API cost. · I'll explain how in a moment.
+One command surface. Best model for each task. Zero dollars with existing subscriptions.
+---</a:t>
             </a:r>
             <a:endParaRPr lang="en-US" dirty="0"/>
           </a:p>
@@ -1308,7 +1327,10 @@
           <a:p>
             <a:r>
               <a:rPr lang="en-US" dirty="0"/>
-              <a:t/>
+              <a:t>Architecturally, there are two layers. · On top: a seven-category router. It classifies every incoming request — coding, writing, math reasoning, analysis, large document, image, or general — and picks the highest-ranked model available for that category, with a fallback chain if the primary provider is unavailable.
+Below that: the team orchestrator. · A leader model reads the request and plans the work — how many teammates to spawn, what specialist role each should play, and which model fits each role. · The teammates run in parallel. · Then the leader reads all their outputs and writes a final synthesis.
+Both the CLI and the optional web UI share the same `src/lib/` core — so the routing logic is identical whether you're running from the terminal or a browser.
+---</a:t>
             </a:r>
             <a:endParaRPr lang="en-US" dirty="0"/>
           </a:p>
@@ -1396,7 +1418,11 @@
           <a:p>
             <a:r>
               <a:rPr lang="en-US" dirty="0"/>
-              <a:t/>
+              <a:t>Now, the key innovation. · Most multi-model agent setups charge you per token for every model call. · This one doesn't have to.
+Here's the idea: many developers already pay flat monthly subscriptions for Claude, Gemini, and Codex CLI tools. · Tokens consumed through those CLI binaries don't incur additional API charges. · So if the binary is installed, I route the call through it using `child_process.spawn` instead of the API.
+The `--use-cli` flag probes for three binaries at startup: `claude`, `gemini`, and `codex`. · If the binary is there and authenticated, that teammate costs zero API tokens.
+The result you're seeing here: three models, ninety-one seconds, total cost **zero dollars**. · If you already pay for these subscriptions, you get a parallel AI team for free.
+---</a:t>
             </a:r>
             <a:endParaRPr lang="en-US" dirty="0"/>
           </a:p>
@@ -1484,7 +1510,8 @@
           <a:p>
             <a:r>
               <a:rPr lang="en-US" dirty="0"/>
-              <a:t/>
+              <a:t>Here's a quick demo of the CLI in action. · You can see the smart-router receiving a prompt, the router classifying it as a coding task, routing it to Claude Sonnet, and streaming the response back — all in a single command. · The verbose flag shows the routing decision and cost.
+---</a:t>
             </a:r>
             <a:endParaRPr lang="en-US" dirty="0"/>
           </a:p>
@@ -1572,7 +1599,8 @@
           <a:p>
             <a:r>
               <a:rPr lang="en-US" dirty="0"/>
-              <a:t/>
+              <a:t>And here's team mode. · You can see the four stages: the initial team page with the CLI provider status badges — Claude connected, Gemini connected — · then the task is submitted, · you get a live dashboard while the teammates run in parallel with per-teammate timers, · and finally the synthesis block with the complete final report and a copy button. · Total cost: zero.
+---</a:t>
             </a:r>
             <a:endParaRPr lang="en-US" dirty="0"/>
           </a:p>
@@ -1660,7 +1688,10 @@
           <a:p>
             <a:r>
               <a:rPr lang="en-US" dirty="0"/>
-              <a:t/>
+              <a:t>Beyond the CLI, I built an optional web UI — deployed at the URL on screen. · It exposes the same routing logic as the CLI, just through a browser interface.
+The main additions are: · GitHub OAuth login via Supabase, · AES-256 encrypted API key storage that syncs across devices, · and the team mode dashboard with live updates over SSE — that's Server-Sent Events — so you see each teammate's progress in real time, with timers, a progress bar, and an expand-all button for reviewing individual results.
+The CLI and the web share the same `src/lib/` core, so any improvement to the router automatically applies to both surfaces.
+---</a:t>
             </a:r>
             <a:endParaRPr lang="en-US" dirty="0"/>
           </a:p>
@@ -1748,7 +1779,8 @@
           <a:p>
             <a:r>
               <a:rPr lang="en-US" dirty="0"/>
-              <a:t/>
+              <a:t>Here's what the web UI looks like. · On the left you see the smart-routed chat — the model pill shows which model handled the request. · On the right, the team mode dashboard: CLI status badges at the top, live progress bar in the middle, and the synthesis block at the bottom once everything completes.
+---</a:t>
             </a:r>
             <a:endParaRPr lang="en-US" dirty="0"/>
           </a:p>
@@ -9480,48 +9512,32 @@
           </a:ln>
         </p:spPr>
       </p:sp>
-      <p:sp>
-        <p:nvSpPr>
-          <p:cNvPr id="5" name="Text 3"/>
-          <p:cNvSpPr/>
-          <p:nvPr/>
-        </p:nvSpPr>
-        <p:spPr>
-          <a:xfrm>
-            <a:off x="914400" y="2103120"/>
-            <a:ext cx="7315200" cy="1097280"/>
-          </a:xfrm>
-          <a:prstGeom prst="rect">
-            <a:avLst/>
-          </a:prstGeom>
-          <a:noFill/>
-          <a:ln/>
-        </p:spPr>
-        <p:txBody>
-          <a:bodyPr wrap="square" lIns="0" tIns="0" rIns="0" bIns="0" rtlCol="0" anchor="ctr"/>
-          <a:lstStyle/>
-          <a:p>
-            <a:pPr algn="ctr" indent="0" marL="0">
-              <a:buNone/>
-            </a:pPr>
-            <a:r>
-              <a:rPr lang="en-US" sz="1800" dirty="0">
-                <a:solidFill>
-                  <a:srgbClr val="9CA3AF"/>
-                </a:solidFill>
-                <a:latin typeface="Consolas" pitchFamily="34" charset="0"/>
-                <a:ea typeface="Consolas" pitchFamily="34" charset="-122"/>
-                <a:cs typeface="Consolas" pitchFamily="34" charset="-120"/>
-              </a:rPr>
-              <a:t>[ demo-cli.gif ]</a:t>
-            </a:r>
-            <a:endParaRPr lang="en-US" sz="1800" dirty="0"/>
-          </a:p>
-        </p:txBody>
-      </p:sp>
-      <p:sp>
-        <p:nvSpPr>
-          <p:cNvPr id="6" name="Text 4"/>
+      <p:pic>
+        <p:nvPicPr>
+          <p:cNvPr id="5" name="Image 0" descr="/Users/junemog/Documents/GitHub/llm-smart-router/presentation/demo-cli.gif">    </p:cNvPr>
+          <p:cNvPicPr>
+            <a:picLocks noChangeAspect="1"/>
+          </p:cNvPicPr>
+          <p:nvPr/>
+        </p:nvPicPr>
+        <p:blipFill>
+          <a:blip r:embed="rId1"/>
+          <a:srcRect l="0" r="0" t="0" b="0"/>
+          <a:stretch/>
+        </p:blipFill>
+        <p:spPr>
+          <a:xfrm>
+            <a:off x="914400" y="1097280"/>
+            <a:ext cx="7315200" cy="3108960"/>
+          </a:xfrm>
+          <a:prstGeom prst="rect">
+            <a:avLst/>
+          </a:prstGeom>
+        </p:spPr>
+      </p:pic>
+      <p:sp>
+        <p:nvSpPr>
+          <p:cNvPr id="6" name="Text 3"/>
           <p:cNvSpPr/>
           <p:nvPr/>
         </p:nvSpPr>
@@ -9679,48 +9695,32 @@
           </a:ln>
         </p:spPr>
       </p:sp>
-      <p:sp>
-        <p:nvSpPr>
-          <p:cNvPr id="5" name="Text 3"/>
-          <p:cNvSpPr/>
-          <p:nvPr/>
-        </p:nvSpPr>
-        <p:spPr>
-          <a:xfrm>
-            <a:off x="914400" y="2103120"/>
-            <a:ext cx="7315200" cy="1097280"/>
-          </a:xfrm>
-          <a:prstGeom prst="rect">
-            <a:avLst/>
-          </a:prstGeom>
-          <a:noFill/>
-          <a:ln/>
-        </p:spPr>
-        <p:txBody>
-          <a:bodyPr wrap="square" lIns="0" tIns="0" rIns="0" bIns="0" rtlCol="0" anchor="ctr"/>
-          <a:lstStyle/>
-          <a:p>
-            <a:pPr algn="ctr" indent="0" marL="0">
-              <a:buNone/>
-            </a:pPr>
-            <a:r>
-              <a:rPr lang="en-US" sz="1800" dirty="0">
-                <a:solidFill>
-                  <a:srgbClr val="9CA3AF"/>
-                </a:solidFill>
-                <a:latin typeface="Consolas" pitchFamily="34" charset="0"/>
-                <a:ea typeface="Consolas" pitchFamily="34" charset="-122"/>
-                <a:cs typeface="Consolas" pitchFamily="34" charset="-120"/>
-              </a:rPr>
-              <a:t>[ demo-team.gif ]</a:t>
-            </a:r>
-            <a:endParaRPr lang="en-US" sz="1800" dirty="0"/>
-          </a:p>
-        </p:txBody>
-      </p:sp>
-      <p:sp>
-        <p:nvSpPr>
-          <p:cNvPr id="6" name="Text 4"/>
+      <p:pic>
+        <p:nvPicPr>
+          <p:cNvPr id="5" name="Image 0" descr="/Users/junemog/Documents/GitHub/llm-smart-router/presentation/demo-team.gif">    </p:cNvPr>
+          <p:cNvPicPr>
+            <a:picLocks noChangeAspect="1"/>
+          </p:cNvPicPr>
+          <p:nvPr/>
+        </p:nvPicPr>
+        <p:blipFill>
+          <a:blip r:embed="rId1"/>
+          <a:srcRect l="0" r="0" t="0" b="0"/>
+          <a:stretch/>
+        </p:blipFill>
+        <p:spPr>
+          <a:xfrm>
+            <a:off x="914400" y="1097280"/>
+            <a:ext cx="7315200" cy="3108960"/>
+          </a:xfrm>
+          <a:prstGeom prst="rect">
+            <a:avLst/>
+          </a:prstGeom>
+        </p:spPr>
+      </p:pic>
+      <p:sp>
+        <p:nvSpPr>
+          <p:cNvPr id="6" name="Text 3"/>
           <p:cNvSpPr/>
           <p:nvPr/>
         </p:nvSpPr>
@@ -11037,48 +11037,32 @@
           </a:ln>
         </p:spPr>
       </p:sp>
-      <p:sp>
-        <p:nvSpPr>
-          <p:cNvPr id="5" name="Text 3"/>
-          <p:cNvSpPr/>
-          <p:nvPr/>
-        </p:nvSpPr>
-        <p:spPr>
-          <a:xfrm>
-            <a:off x="914400" y="2103120"/>
-            <a:ext cx="7315200" cy="1097280"/>
-          </a:xfrm>
-          <a:prstGeom prst="rect">
-            <a:avLst/>
-          </a:prstGeom>
-          <a:noFill/>
-          <a:ln/>
-        </p:spPr>
-        <p:txBody>
-          <a:bodyPr wrap="square" lIns="0" tIns="0" rIns="0" bIns="0" rtlCol="0" anchor="ctr"/>
-          <a:lstStyle/>
-          <a:p>
-            <a:pPr algn="ctr" indent="0" marL="0">
-              <a:buNone/>
-            </a:pPr>
-            <a:r>
-              <a:rPr lang="en-US" sz="1800" dirty="0">
-                <a:solidFill>
-                  <a:srgbClr val="9CA3AF"/>
-                </a:solidFill>
-                <a:latin typeface="Consolas" pitchFamily="34" charset="0"/>
-                <a:ea typeface="Consolas" pitchFamily="34" charset="-122"/>
-                <a:cs typeface="Consolas" pitchFamily="34" charset="-120"/>
-              </a:rPr>
-              <a:t>[ demo-web.gif ]</a:t>
-            </a:r>
-            <a:endParaRPr lang="en-US" sz="1800" dirty="0"/>
-          </a:p>
-        </p:txBody>
-      </p:sp>
-      <p:sp>
-        <p:nvSpPr>
-          <p:cNvPr id="6" name="Text 4"/>
+      <p:pic>
+        <p:nvPicPr>
+          <p:cNvPr id="5" name="Image 0" descr="/Users/junemog/Documents/GitHub/llm-smart-router/presentation/demo-web.gif">    </p:cNvPr>
+          <p:cNvPicPr>
+            <a:picLocks noChangeAspect="1"/>
+          </p:cNvPicPr>
+          <p:nvPr/>
+        </p:nvPicPr>
+        <p:blipFill>
+          <a:blip r:embed="rId1"/>
+          <a:srcRect l="0" r="0" t="0" b="0"/>
+          <a:stretch/>
+        </p:blipFill>
+        <p:spPr>
+          <a:xfrm>
+            <a:off x="914400" y="1097280"/>
+            <a:ext cx="7315200" cy="3108960"/>
+          </a:xfrm>
+          <a:prstGeom prst="rect">
+            <a:avLst/>
+          </a:prstGeom>
+        </p:spPr>
+      </p:pic>
+      <p:sp>
+        <p:nvSpPr>
+          <p:cNvPr id="6" name="Text 3"/>
           <p:cNvSpPr/>
           <p:nvPr/>
         </p:nvSpPr>

</xml_diff>